<commit_message>
Add 3 extra slides to fusionada: Incomparable Encodings, SUF-CMA, Adaptive Knowledge Soundness
Topics missing from paper 055 now covered as slides 19-21 before Conclusions.

Co-Authored-By: Claude Opus 4.6 <noreply@anthropic.com>
</commit_message>
<xml_diff>
--- a/XMSS_Post_Cuantica_fusionada.pptx
+++ b/XMSS_Post_Cuantica_fusionada.pptx
@@ -23,6 +23,9 @@
     <p:sldId id="266" r:id="rId12"/>
     <p:sldId id="267" r:id="rId13"/>
     <p:sldId id="268" r:id="rId14"/>
+    <p:sldId id="275" r:id="rId26"/>
+    <p:sldId id="276" r:id="rId27"/>
+    <p:sldId id="277" r:id="rId28"/>
     <p:sldId id="269" r:id="rId15"/>
   </p:sldIdLst>
   <p:notesMasterIdLst>
@@ -13248,6 +13251,1282 @@
 </p:sld>
 </file>
 
+<file path=ppt/slides/slide20.xml><?xml version="1.0" encoding="utf-8"?>
+<p:sld xmlns:a="http://schemas.openxmlformats.org/drawingml/2006/main" xmlns:r="http://schemas.openxmlformats.org/officeDocument/2006/relationships" xmlns:p="http://schemas.openxmlformats.org/presentationml/2006/main">
+  <p:cSld name="Slide 20">
+    <p:bg>
+      <p:bgPr>
+        <a:solidFill>
+          <a:srgbClr val="080E1A"/>
+        </a:solidFill>
+      </p:bgPr>
+    </p:bg>
+    <p:spTree>
+      <p:nvGrpSpPr>
+        <p:cNvPr id="1" name=""/>
+        <p:cNvGrpSpPr/>
+        <p:nvPr/>
+      </p:nvGrpSpPr>
+      <p:grpSpPr>
+        <a:xfrm>
+          <a:off x="0" y="0"/>
+          <a:ext cx="0" cy="0"/>
+          <a:chOff x="0" y="0"/>
+          <a:chExt cx="0" cy="0"/>
+        </a:xfrm>
+      </p:grpSpPr>
+      <p:sp>
+        <p:nvSpPr>
+          <p:cNvPr id="2" name="AccentBar"/>
+          <p:cNvSpPr/>
+          <p:nvPr/>
+        </p:nvSpPr>
+        <p:spPr>
+          <a:xfrm>
+            <a:off x="0" y="0"/>
+            <a:ext cx="73152" cy="5143500"/>
+          </a:xfrm>
+          <a:prstGeom prst="rect">
+            <a:avLst/>
+          </a:prstGeom>
+          <a:solidFill>
+            <a:srgbClr val="F59E0B"/>
+          </a:solidFill>
+          <a:ln w="12700">
+            <a:solidFill>
+              <a:srgbClr val="333333"/>
+            </a:solidFill>
+          </a:ln>
+        </p:spPr>
+      </p:sp>
+      <p:sp>
+        <p:nvSpPr>
+          <p:cNvPr id="3" name="Title"/>
+          <p:cNvSpPr/>
+          <p:nvPr/>
+        </p:nvSpPr>
+        <p:spPr>
+          <a:xfrm>
+            <a:off x="274320" y="182880"/>
+            <a:ext cx="8595360" cy="548640"/>
+          </a:xfrm>
+          <a:prstGeom prst="rect">
+            <a:avLst/>
+          </a:prstGeom>
+          <a:noFill/>
+          <a:ln/>
+        </p:spPr>
+        <p:txBody>
+          <a:bodyPr wrap="square" lIns="0" tIns="0" rIns="0" bIns="0" rtlCol="0" anchor="ctr"/>
+          <a:lstStyle/>
+          <a:p>
+            <a:pPr indent="0" marL="0">
+              <a:buNone/>
+            </a:pPr>
+            <a:r>
+              <a:rPr lang="es-AR" sz="2600" b="1" dirty="0">
+                <a:solidFill>
+                  <a:srgbClr val="F8FAFC"/>
+                </a:solidFill>
+                <a:latin typeface="Arial" pitchFamily="34" charset="0"/>
+              </a:rPr>
+              <a:t>Incomparable Encodings</a:t>
+            </a:r>
+          </a:p>
+        </p:txBody>
+      </p:sp>
+      <p:sp>
+        <p:nvSpPr>
+          <p:cNvPr id="4" name="Subtitle"/>
+          <p:cNvSpPr/>
+          <p:nvPr/>
+        </p:nvSpPr>
+        <p:spPr>
+          <a:xfrm>
+            <a:off x="274320" y="731520"/>
+            <a:ext cx="8595360" cy="320040"/>
+          </a:xfrm>
+          <a:prstGeom prst="rect">
+            <a:avLst/>
+          </a:prstGeom>
+          <a:noFill/>
+          <a:ln/>
+        </p:spPr>
+        <p:txBody>
+          <a:bodyPr wrap="square" lIns="0" tIns="0" rIns="0" bIns="0" rtlCol="0" anchor="t"/>
+          <a:lstStyle/>
+          <a:p>
+            <a:pPr indent="0" marL="0">
+              <a:buNone/>
+            </a:pPr>
+            <a:r>
+              <a:rPr lang="es-AR" sz="1250" i="1" dirty="0">
+                <a:solidFill>
+                  <a:srgbClr val="BFDBFE"/>
+                </a:solidFill>
+              </a:rPr>
+              <a:t>Framework unificador para variantes de XMSS — Drake et al. (2024)</a:t>
+            </a:r>
+          </a:p>
+        </p:txBody>
+      </p:sp>
+      <p:sp>
+        <p:nvSpPr>
+          <p:cNvPr id="5" name="Sep"/>
+          <p:cNvSpPr/>
+          <p:nvPr/>
+        </p:nvSpPr>
+        <p:spPr>
+          <a:xfrm>
+            <a:off x="274320" y="1051560"/>
+            <a:ext cx="8412480" cy="0"/>
+          </a:xfrm>
+          <a:prstGeom prst="line">
+            <a:avLst/>
+          </a:prstGeom>
+          <a:noFill/>
+          <a:ln w="12700">
+            <a:solidFill>
+              <a:srgbClr val="1E3A5F"/>
+            </a:solidFill>
+          </a:ln>
+        </p:spPr>
+      </p:sp>
+      <p:sp>
+        <p:nvSpPr>
+          <p:cNvPr id="6" name="BoxLeftBg"/>
+          <p:cNvSpPr/>
+          <p:nvPr/>
+        </p:nvSpPr>
+        <p:spPr>
+          <a:xfrm>
+            <a:off x="274320" y="1143000"/>
+            <a:ext cx="4206240" cy="3657600"/>
+          </a:xfrm>
+          <a:prstGeom prst="rect">
+            <a:avLst/>
+          </a:prstGeom>
+          <a:solidFill>
+            <a:srgbClr val="0F1E3D"/>
+          </a:solidFill>
+          <a:ln w="19050">
+            <a:solidFill>
+              <a:srgbClr val="F59E0B"/>
+            </a:solidFill>
+          </a:ln>
+        </p:spPr>
+      </p:sp>
+      <p:sp>
+        <p:nvSpPr>
+          <p:cNvPr id="7" name="BoxLeftText"/>
+          <p:cNvSpPr/>
+          <p:nvPr/>
+        </p:nvSpPr>
+        <p:spPr>
+          <a:xfrm>
+            <a:off x="365760" y="1188720"/>
+            <a:ext cx="4023360" cy="3566160"/>
+          </a:xfrm>
+          <a:prstGeom prst="rect">
+            <a:avLst/>
+          </a:prstGeom>
+          <a:noFill/>
+          <a:ln/>
+        </p:spPr>
+        <p:txBody>
+          <a:bodyPr wrap="square" lIns="91440" tIns="45720" rIns="91440" bIns="45720" rtlCol="0" anchor="t"/>
+          <a:lstStyle/>
+          <a:p>
+            <a:pPr indent="0" marL="0">
+              <a:buNone/>
+            </a:pPr>
+            <a:r>
+              <a:rPr lang="es-AR" sz="1400" b="1" dirty="0">
+                <a:solidFill>
+                  <a:srgbClr val="F59E0B"/>
+                </a:solidFill>
+                <a:latin typeface="Arial" pitchFamily="34" charset="0"/>
+              </a:rPr>
+              <a:t>¿Qué es?</a:t>
+            </a:r>
+          </a:p>
+          <a:p>
+            <a:pPr indent="0" marL="0">
+              <a:buNone/>
+            </a:pPr>
+            <a:r>
+              <a:rPr lang="es-AR" sz="1050" dirty="0">
+                <a:solidFill>
+                  <a:srgbClr val="BFDBFE"/>
+                </a:solidFill>
+              </a:rPr>
+              <a:t>Un encoding IncEnc mapea mensajes a codewords en un espacio tal que cualesquiera dos codewords distintos son incomparables.</a:t>
+            </a:r>
+          </a:p>
+          <a:p>
+            <a:pPr indent="0" marL="0">
+              <a:buNone/>
+            </a:pPr>
+            <a:endParaRPr lang="es-AR" sz="600" dirty="0"/>
+          </a:p>
+          <a:p>
+            <a:pPr indent="0" marL="0">
+              <a:buNone/>
+            </a:pPr>
+            <a:r>
+              <a:rPr lang="es-AR" sz="1400" b="1" dirty="0">
+                <a:solidFill>
+                  <a:srgbClr val="F59E0B"/>
+                </a:solidFill>
+                <a:latin typeface="Arial" pitchFamily="34" charset="0"/>
+              </a:rPr>
+              <a:t>Incomparabilidad</a:t>
+            </a:r>
+          </a:p>
+          <a:p>
+            <a:pPr indent="0" marL="0">
+              <a:buNone/>
+            </a:pPr>
+            <a:r>
+              <a:rPr lang="es-AR" sz="1050" dirty="0">
+                <a:solidFill>
+                  <a:srgbClr val="BFDBFE"/>
+                </a:solidFill>
+              </a:rPr>
+              <a:t>Para dos codewords x y x', siempre existe algún índice donde x_i &lt; x'_i y otro donde x'_j &lt; x_j. Ningún codeword domina a otro coordenada a coordenada.</a:t>
+            </a:r>
+          </a:p>
+          <a:p>
+            <a:pPr indent="0" marL="0">
+              <a:buNone/>
+            </a:pPr>
+            <a:endParaRPr lang="es-AR" sz="600" dirty="0"/>
+          </a:p>
+          <a:p>
+            <a:pPr indent="0" marL="0">
+              <a:buNone/>
+            </a:pPr>
+            <a:r>
+              <a:rPr lang="es-AR" sz="1050" dirty="0">
+                <a:solidFill>
+                  <a:srgbClr val="94A3B8"/>
+                </a:solidFill>
+              </a:rPr>
+              <a:t>Sin esta propiedad, un adversario podría falsificar firmas “subiendo” valores en las cadenas de hash.</a:t>
+            </a:r>
+          </a:p>
+        </p:txBody>
+      </p:sp>
+      <p:sp>
+        <p:nvSpPr>
+          <p:cNvPr id="8" name="BoxRightBg"/>
+          <p:cNvSpPr/>
+          <p:nvPr/>
+        </p:nvSpPr>
+        <p:spPr>
+          <a:xfrm>
+            <a:off x="4663440" y="1143000"/>
+            <a:ext cx="4206240" cy="3657600"/>
+          </a:xfrm>
+          <a:prstGeom prst="rect">
+            <a:avLst/>
+          </a:prstGeom>
+          <a:solidFill>
+            <a:srgbClr val="0F1E3D"/>
+          </a:solidFill>
+          <a:ln w="19050">
+            <a:solidFill>
+              <a:srgbClr val="10B981"/>
+            </a:solidFill>
+          </a:ln>
+        </p:spPr>
+      </p:sp>
+      <p:sp>
+        <p:nvSpPr>
+          <p:cNvPr id="9" name="BoxRightText"/>
+          <p:cNvSpPr/>
+          <p:nvPr/>
+        </p:nvSpPr>
+        <p:spPr>
+          <a:xfrm>
+            <a:off x="4754880" y="1188720"/>
+            <a:ext cx="4023360" cy="3566160"/>
+          </a:xfrm>
+          <a:prstGeom prst="rect">
+            <a:avLst/>
+          </a:prstGeom>
+          <a:noFill/>
+          <a:ln/>
+        </p:spPr>
+        <p:txBody>
+          <a:bodyPr wrap="square" lIns="91440" tIns="45720" rIns="91440" bIns="45720" rtlCol="0" anchor="t"/>
+          <a:lstStyle/>
+          <a:p>
+            <a:pPr indent="0" marL="0">
+              <a:buNone/>
+            </a:pPr>
+            <a:r>
+              <a:rPr lang="es-AR" sz="1400" b="1" dirty="0">
+                <a:solidFill>
+                  <a:srgbClr val="10B981"/>
+                </a:solidFill>
+                <a:latin typeface="Arial" pitchFamily="34" charset="0"/>
+              </a:rPr>
+              <a:t>¿Por qué importa?</a:t>
+            </a:r>
+          </a:p>
+          <a:p>
+            <a:pPr indent="0" marL="0">
+              <a:buNone/>
+            </a:pPr>
+            <a:r>
+              <a:rPr lang="es-AR" sz="1050" dirty="0">
+                <a:solidFill>
+                  <a:srgbClr val="BFDBFE"/>
+                </a:solidFill>
+              </a:rPr>
+              <a:t>Permite abstraer la prueba de seguridad de XMSS: cualquier encoding incomparable válido produce un esquema seguro, con una única prueba genérica.</a:t>
+            </a:r>
+          </a:p>
+          <a:p>
+            <a:pPr indent="0" marL="0">
+              <a:buNone/>
+            </a:pPr>
+            <a:endParaRPr lang="es-AR" sz="600" dirty="0"/>
+          </a:p>
+          <a:p>
+            <a:pPr indent="0" marL="0">
+              <a:buNone/>
+            </a:pPr>
+            <a:r>
+              <a:rPr lang="es-AR" sz="1400" b="1" dirty="0">
+                <a:solidFill>
+                  <a:srgbClr val="10B981"/>
+                </a:solidFill>
+                <a:latin typeface="Arial" pitchFamily="34" charset="0"/>
+              </a:rPr>
+              <a:t>Dos instancias</a:t>
+            </a:r>
+          </a:p>
+          <a:p>
+            <a:pPr indent="0" marL="0">
+              <a:buNone/>
+            </a:pPr>
+            <a:r>
+              <a:rPr lang="es-AR" sz="1050" b="1" dirty="0">
+                <a:solidFill>
+                  <a:srgbClr val="F59E0B"/>
+                </a:solidFill>
+              </a:rPr>
+              <a:t xml:space="preserve">Winternitz clásico: </a:t>
+            </a:r>
+            <a:r>
+              <a:rPr lang="es-AR" sz="1050" dirty="0">
+                <a:solidFill>
+                  <a:srgbClr val="BFDBFE"/>
+                </a:solidFill>
+              </a:rPr>
+              <a:t>hashing del mensaje + checksum. Error δ = 0 (nunca falla). Costo de verificación variable.</a:t>
+            </a:r>
+          </a:p>
+          <a:p>
+            <a:pPr indent="0" marL="0">
+              <a:buNone/>
+            </a:pPr>
+            <a:endParaRPr lang="es-AR" sz="600" dirty="0"/>
+          </a:p>
+          <a:p>
+            <a:pPr indent="0" marL="0">
+              <a:buNone/>
+            </a:pPr>
+            <a:r>
+              <a:rPr lang="es-AR" sz="1050" b="1" dirty="0">
+                <a:solidFill>
+                  <a:srgbClr val="F59E0B"/>
+                </a:solidFill>
+              </a:rPr>
+              <a:t xml:space="preserve">Target Sum Winternitz: </a:t>
+            </a:r>
+            <a:r>
+              <a:rPr lang="es-AR" sz="1050" dirty="0">
+                <a:solidFill>
+                  <a:srgbClr val="BFDBFE"/>
+                </a:solidFill>
+              </a:rPr>
+              <a:t>sin checksum, suma fija = T. Costo de verificación determinista → circuito SNARK predecible.</a:t>
+            </a:r>
+          </a:p>
+          <a:p>
+            <a:pPr indent="0" marL="0">
+              <a:buNone/>
+            </a:pPr>
+            <a:endParaRPr lang="es-AR" sz="600" dirty="0"/>
+          </a:p>
+          <a:p>
+            <a:pPr indent="0" marL="0">
+              <a:buNone/>
+            </a:pPr>
+            <a:r>
+              <a:rPr lang="es-AR" sz="1050" dirty="0">
+                <a:solidFill>
+                  <a:srgbClr val="94A3B8"/>
+                </a:solidFill>
+              </a:rPr>
+              <a:t>Ambas son instancias del mismo framework, con una sola prueba de seguridad que cubre las dos.</a:t>
+            </a:r>
+          </a:p>
+        </p:txBody>
+      </p:sp>
+    </p:spTree>
+  </p:cSld>
+</p:sld>
+</file>
+
+<file path=ppt/slides/slide21.xml><?xml version="1.0" encoding="utf-8"?>
+<p:sld xmlns:a="http://schemas.openxmlformats.org/drawingml/2006/main" xmlns:r="http://schemas.openxmlformats.org/officeDocument/2006/relationships" xmlns:p="http://schemas.openxmlformats.org/presentationml/2006/main">
+  <p:cSld name="Slide 21">
+    <p:bg>
+      <p:bgPr>
+        <a:solidFill>
+          <a:srgbClr val="080E1A"/>
+        </a:solidFill>
+      </p:bgPr>
+    </p:bg>
+    <p:spTree>
+      <p:nvGrpSpPr>
+        <p:cNvPr id="1" name=""/>
+        <p:cNvGrpSpPr/>
+        <p:nvPr/>
+      </p:nvGrpSpPr>
+      <p:grpSpPr>
+        <a:xfrm>
+          <a:off x="0" y="0"/>
+          <a:ext cx="0" cy="0"/>
+          <a:chOff x="0" y="0"/>
+          <a:chExt cx="0" cy="0"/>
+        </a:xfrm>
+      </p:grpSpPr>
+      <p:sp>
+        <p:nvSpPr>
+          <p:cNvPr id="2" name="AccentBar"/>
+          <p:cNvSpPr/>
+          <p:nvPr/>
+        </p:nvSpPr>
+        <p:spPr>
+          <a:xfrm>
+            <a:off x="0" y="0"/>
+            <a:ext cx="73152" cy="5143500"/>
+          </a:xfrm>
+          <a:prstGeom prst="rect">
+            <a:avLst/>
+          </a:prstGeom>
+          <a:solidFill>
+            <a:srgbClr val="A78BFA"/>
+          </a:solidFill>
+          <a:ln w="12700">
+            <a:solidFill>
+              <a:srgbClr val="333333"/>
+            </a:solidFill>
+          </a:ln>
+        </p:spPr>
+      </p:sp>
+      <p:sp>
+        <p:nvSpPr>
+          <p:cNvPr id="3" name="Title"/>
+          <p:cNvSpPr/>
+          <p:nvPr/>
+        </p:nvSpPr>
+        <p:spPr>
+          <a:xfrm>
+            <a:off x="274320" y="182880"/>
+            <a:ext cx="8595360" cy="548640"/>
+          </a:xfrm>
+          <a:prstGeom prst="rect">
+            <a:avLst/>
+          </a:prstGeom>
+          <a:noFill/>
+          <a:ln/>
+        </p:spPr>
+        <p:txBody>
+          <a:bodyPr wrap="square" lIns="0" tIns="0" rIns="0" bIns="0" rtlCol="0" anchor="ctr"/>
+          <a:lstStyle/>
+          <a:p>
+            <a:pPr indent="0" marL="0">
+              <a:buNone/>
+            </a:pPr>
+            <a:r>
+              <a:rPr lang="es-AR" sz="2600" b="1" dirty="0">
+                <a:solidFill>
+                  <a:srgbClr val="F8FAFC"/>
+                </a:solidFill>
+                <a:latin typeface="Arial" pitchFamily="34" charset="0"/>
+              </a:rPr>
+              <a:t>Strong Unforgeability (SUF-CMA)</a:t>
+            </a:r>
+          </a:p>
+        </p:txBody>
+      </p:sp>
+      <p:sp>
+        <p:nvSpPr>
+          <p:cNvPr id="4" name="Subtitle"/>
+          <p:cNvSpPr/>
+          <p:nvPr/>
+        </p:nvSpPr>
+        <p:spPr>
+          <a:xfrm>
+            <a:off x="274320" y="731520"/>
+            <a:ext cx="8595360" cy="320040"/>
+          </a:xfrm>
+          <a:prstGeom prst="rect">
+            <a:avLst/>
+          </a:prstGeom>
+          <a:noFill/>
+          <a:ln/>
+        </p:spPr>
+        <p:txBody>
+          <a:bodyPr wrap="square" lIns="0" tIns="0" rIns="0" bIns="0" rtlCol="0" anchor="t"/>
+          <a:lstStyle/>
+          <a:p>
+            <a:pPr indent="0" marL="0">
+              <a:buNone/>
+            </a:pPr>
+            <a:r>
+              <a:rPr lang="es-AR" sz="1250" i="1" dirty="0">
+                <a:solidFill>
+                  <a:srgbClr val="BFDBFE"/>
+                </a:solidFill>
+              </a:rPr>
+              <a:t>Primera prueba de XMSS con noción fuerte de seguridad</a:t>
+            </a:r>
+          </a:p>
+        </p:txBody>
+      </p:sp>
+      <p:sp>
+        <p:nvSpPr>
+          <p:cNvPr id="5" name="Sep"/>
+          <p:cNvSpPr/>
+          <p:nvPr/>
+        </p:nvSpPr>
+        <p:spPr>
+          <a:xfrm>
+            <a:off x="274320" y="1051560"/>
+            <a:ext cx="8412480" cy="0"/>
+          </a:xfrm>
+          <a:prstGeom prst="line">
+            <a:avLst/>
+          </a:prstGeom>
+          <a:noFill/>
+          <a:ln w="12700">
+            <a:solidFill>
+              <a:srgbClr val="1E3A5F"/>
+            </a:solidFill>
+          </a:ln>
+        </p:spPr>
+      </p:sp>
+      <p:sp>
+        <p:nvSpPr>
+          <p:cNvPr id="6" name="BoxLeftBg"/>
+          <p:cNvSpPr/>
+          <p:nvPr/>
+        </p:nvSpPr>
+        <p:spPr>
+          <a:xfrm>
+            <a:off x="274320" y="1143000"/>
+            <a:ext cx="4206240" cy="2286000"/>
+          </a:xfrm>
+          <a:prstGeom prst="rect">
+            <a:avLst/>
+          </a:prstGeom>
+          <a:solidFill>
+            <a:srgbClr val="0F1E3D"/>
+          </a:solidFill>
+          <a:ln w="19050">
+            <a:solidFill>
+              <a:srgbClr val="3B82F6"/>
+            </a:solidFill>
+          </a:ln>
+        </p:spPr>
+      </p:sp>
+      <p:sp>
+        <p:nvSpPr>
+          <p:cNvPr id="7" name="BoxLeftText"/>
+          <p:cNvSpPr/>
+          <p:nvPr/>
+        </p:nvSpPr>
+        <p:spPr>
+          <a:xfrm>
+            <a:off x="365760" y="1188720"/>
+            <a:ext cx="4023360" cy="2194560"/>
+          </a:xfrm>
+          <a:prstGeom prst="rect">
+            <a:avLst/>
+          </a:prstGeom>
+          <a:noFill/>
+          <a:ln/>
+        </p:spPr>
+        <p:txBody>
+          <a:bodyPr wrap="square" lIns="91440" tIns="45720" rIns="91440" bIns="45720" rtlCol="0" anchor="t"/>
+          <a:lstStyle/>
+          <a:p>
+            <a:pPr indent="0" marL="0">
+              <a:buNone/>
+            </a:pPr>
+            <a:r>
+              <a:rPr lang="es-AR" sz="1400" b="1" dirty="0">
+                <a:solidFill>
+                  <a:srgbClr val="3B82F6"/>
+                </a:solidFill>
+                <a:latin typeface="Arial" pitchFamily="34" charset="0"/>
+              </a:rPr>
+              <a:t>EUF-CMA (clásica)</a:t>
+            </a:r>
+          </a:p>
+          <a:p>
+            <a:pPr indent="0" marL="0">
+              <a:buNone/>
+            </a:pPr>
+            <a:r>
+              <a:rPr lang="es-AR" sz="1100" dirty="0">
+                <a:solidFill>
+                  <a:srgbClr val="BFDBFE"/>
+                </a:solidFill>
+              </a:rPr>
+              <a:t>El adversario no puede producir una firma válida para un mensaje que nunca fue firmado.</a:t>
+            </a:r>
+          </a:p>
+          <a:p>
+            <a:pPr indent="0" marL="0">
+              <a:buNone/>
+            </a:pPr>
+            <a:endParaRPr lang="es-AR" sz="600" dirty="0"/>
+          </a:p>
+          <a:p>
+            <a:pPr indent="0" marL="0">
+              <a:buNone/>
+            </a:pPr>
+            <a:r>
+              <a:rPr lang="es-AR" sz="1100" dirty="0">
+                <a:solidFill>
+                  <a:srgbClr val="94A3B8"/>
+                </a:solidFill>
+              </a:rPr>
+              <a:t>Todos los trabajos previos sobre XMSS solo probaban esta noción.</a:t>
+            </a:r>
+          </a:p>
+        </p:txBody>
+      </p:sp>
+      <p:sp>
+        <p:nvSpPr>
+          <p:cNvPr id="8" name="BoxRightBg"/>
+          <p:cNvSpPr/>
+          <p:nvPr/>
+        </p:nvSpPr>
+        <p:spPr>
+          <a:xfrm>
+            <a:off x="4663440" y="1143000"/>
+            <a:ext cx="4206240" cy="2286000"/>
+          </a:xfrm>
+          <a:prstGeom prst="rect">
+            <a:avLst/>
+          </a:prstGeom>
+          <a:solidFill>
+            <a:srgbClr val="0F1E3D"/>
+          </a:solidFill>
+          <a:ln w="19050">
+            <a:solidFill>
+              <a:srgbClr val="A78BFA"/>
+            </a:solidFill>
+          </a:ln>
+        </p:spPr>
+      </p:sp>
+      <p:sp>
+        <p:nvSpPr>
+          <p:cNvPr id="9" name="BoxRightText"/>
+          <p:cNvSpPr/>
+          <p:nvPr/>
+        </p:nvSpPr>
+        <p:spPr>
+          <a:xfrm>
+            <a:off x="4754880" y="1188720"/>
+            <a:ext cx="4023360" cy="2194560"/>
+          </a:xfrm>
+          <a:prstGeom prst="rect">
+            <a:avLst/>
+          </a:prstGeom>
+          <a:noFill/>
+          <a:ln/>
+        </p:spPr>
+        <p:txBody>
+          <a:bodyPr wrap="square" lIns="91440" tIns="45720" rIns="91440" bIns="45720" rtlCol="0" anchor="t"/>
+          <a:lstStyle/>
+          <a:p>
+            <a:pPr indent="0" marL="0">
+              <a:buNone/>
+            </a:pPr>
+            <a:r>
+              <a:rPr lang="es-AR" sz="1400" b="1" dirty="0">
+                <a:solidFill>
+                  <a:srgbClr val="A78BFA"/>
+                </a:solidFill>
+                <a:latin typeface="Arial" pitchFamily="34" charset="0"/>
+              </a:rPr>
+              <a:t>SUF-CMA (fuerte)</a:t>
+            </a:r>
+          </a:p>
+          <a:p>
+            <a:pPr indent="0" marL="0">
+              <a:buNone/>
+            </a:pPr>
+            <a:r>
+              <a:rPr lang="es-AR" sz="1100" dirty="0">
+                <a:solidFill>
+                  <a:srgbClr val="BFDBFE"/>
+                </a:solidFill>
+              </a:rPr>
+              <a:t>El adversario no puede producir ninguna firma nueva, ni siquiera para un mensaje ya firmado (con una firma diferente).</a:t>
+            </a:r>
+          </a:p>
+          <a:p>
+            <a:pPr indent="0" marL="0">
+              <a:buNone/>
+            </a:pPr>
+            <a:endParaRPr lang="es-AR" sz="600" dirty="0"/>
+          </a:p>
+          <a:p>
+            <a:pPr indent="0" marL="0">
+              <a:buNone/>
+            </a:pPr>
+            <a:r>
+              <a:rPr lang="es-AR" sz="1100" b="1" dirty="0">
+                <a:solidFill>
+                  <a:srgbClr val="A78BFA"/>
+                </a:solidFill>
+              </a:rPr>
+              <a:t>Primera prueba de XMSS con SUF-CMA.</a:t>
+            </a:r>
+          </a:p>
+        </p:txBody>
+      </p:sp>
+      <p:sp>
+        <p:nvSpPr>
+          <p:cNvPr id="10" name="BoxBottomBg"/>
+          <p:cNvSpPr/>
+          <p:nvPr/>
+        </p:nvSpPr>
+        <p:spPr>
+          <a:xfrm>
+            <a:off x="274320" y="3566160"/>
+            <a:ext cx="8595360" cy="1371600"/>
+          </a:xfrm>
+          <a:prstGeom prst="rect">
+            <a:avLst/>
+          </a:prstGeom>
+          <a:solidFill>
+            <a:srgbClr val="0F1E3D"/>
+          </a:solidFill>
+          <a:ln w="19050">
+            <a:solidFill>
+              <a:srgbClr val="10B981"/>
+            </a:solidFill>
+          </a:ln>
+        </p:spPr>
+      </p:sp>
+      <p:sp>
+        <p:nvSpPr>
+          <p:cNvPr id="11" name="BoxBottomText"/>
+          <p:cNvSpPr/>
+          <p:nvPr/>
+        </p:nvSpPr>
+        <p:spPr>
+          <a:xfrm>
+            <a:off x="365760" y="3611880"/>
+            <a:ext cx="8412480" cy="1280160"/>
+          </a:xfrm>
+          <a:prstGeom prst="rect">
+            <a:avLst/>
+          </a:prstGeom>
+          <a:noFill/>
+          <a:ln/>
+        </p:spPr>
+        <p:txBody>
+          <a:bodyPr wrap="square" lIns="91440" tIns="45720" rIns="91440" bIns="45720" rtlCol="0" anchor="t"/>
+          <a:lstStyle/>
+          <a:p>
+            <a:pPr indent="0" marL="0">
+              <a:buNone/>
+            </a:pPr>
+            <a:r>
+              <a:rPr lang="es-AR" sz="1400" b="1" dirty="0">
+                <a:solidFill>
+                  <a:srgbClr val="10B981"/>
+                </a:solidFill>
+                <a:latin typeface="Arial" pitchFamily="34" charset="0"/>
+              </a:rPr>
+              <a:t>¿Por qué importa para Ethereum?</a:t>
+            </a:r>
+          </a:p>
+          <a:p>
+            <a:pPr indent="0" marL="0">
+              <a:buNone/>
+            </a:pPr>
+            <a:r>
+              <a:rPr lang="es-AR" sz="1100" dirty="0">
+                <a:solidFill>
+                  <a:srgbClr val="BFDBFE"/>
+                </a:solidFill>
+              </a:rPr>
+              <a:t>En sistemas complejos como Ethereum, la firma pasa por múltiples capas (agregación, SNARK, consenso). SUF-CMA garantiza que un adversario no pueda crear firmas alternativas que parezcan legítimas y manipulen el consenso, incluso si observó firmas válidas previas del mismo validador.</a:t>
+            </a:r>
+          </a:p>
+        </p:txBody>
+      </p:sp>
+    </p:spTree>
+  </p:cSld>
+</p:sld>
+</file>
+
+<file path=ppt/slides/slide22.xml><?xml version="1.0" encoding="utf-8"?>
+<p:sld xmlns:a="http://schemas.openxmlformats.org/drawingml/2006/main" xmlns:r="http://schemas.openxmlformats.org/officeDocument/2006/relationships" xmlns:p="http://schemas.openxmlformats.org/presentationml/2006/main">
+  <p:cSld name="Slide 22">
+    <p:bg>
+      <p:bgPr>
+        <a:solidFill>
+          <a:srgbClr val="080E1A"/>
+        </a:solidFill>
+      </p:bgPr>
+    </p:bg>
+    <p:spTree>
+      <p:nvGrpSpPr>
+        <p:cNvPr id="1" name=""/>
+        <p:cNvGrpSpPr/>
+        <p:nvPr/>
+      </p:nvGrpSpPr>
+      <p:grpSpPr>
+        <a:xfrm>
+          <a:off x="0" y="0"/>
+          <a:ext cx="0" cy="0"/>
+          <a:chOff x="0" y="0"/>
+          <a:chExt cx="0" cy="0"/>
+        </a:xfrm>
+      </p:grpSpPr>
+      <p:sp>
+        <p:nvSpPr>
+          <p:cNvPr id="2" name="AccentBar"/>
+          <p:cNvSpPr/>
+          <p:nvPr/>
+        </p:nvSpPr>
+        <p:spPr>
+          <a:xfrm>
+            <a:off x="0" y="0"/>
+            <a:ext cx="73152" cy="5143500"/>
+          </a:xfrm>
+          <a:prstGeom prst="rect">
+            <a:avLst/>
+          </a:prstGeom>
+          <a:solidFill>
+            <a:srgbClr val="EF4444"/>
+          </a:solidFill>
+          <a:ln w="12700">
+            <a:solidFill>
+              <a:srgbClr val="333333"/>
+            </a:solidFill>
+          </a:ln>
+        </p:spPr>
+      </p:sp>
+      <p:sp>
+        <p:nvSpPr>
+          <p:cNvPr id="3" name="Title"/>
+          <p:cNvSpPr/>
+          <p:nvPr/>
+        </p:nvSpPr>
+        <p:spPr>
+          <a:xfrm>
+            <a:off x="274320" y="182880"/>
+            <a:ext cx="8595360" cy="548640"/>
+          </a:xfrm>
+          <a:prstGeom prst="rect">
+            <a:avLst/>
+          </a:prstGeom>
+          <a:noFill/>
+          <a:ln/>
+        </p:spPr>
+        <p:txBody>
+          <a:bodyPr wrap="square" lIns="0" tIns="0" rIns="0" bIns="0" rtlCol="0" anchor="ctr"/>
+          <a:lstStyle/>
+          <a:p>
+            <a:pPr indent="0" marL="0">
+              <a:buNone/>
+            </a:pPr>
+            <a:r>
+              <a:rPr lang="es-AR" sz="2600" b="1" dirty="0">
+                <a:solidFill>
+                  <a:srgbClr val="F8FAFC"/>
+                </a:solidFill>
+                <a:latin typeface="Arial" pitchFamily="34" charset="0"/>
+              </a:rPr>
+              <a:t>Adaptive Knowledge Soundness</a:t>
+            </a:r>
+          </a:p>
+        </p:txBody>
+      </p:sp>
+      <p:sp>
+        <p:nvSpPr>
+          <p:cNvPr id="4" name="Subtitle"/>
+          <p:cNvSpPr/>
+          <p:nvPr/>
+        </p:nvSpPr>
+        <p:spPr>
+          <a:xfrm>
+            <a:off x="274320" y="731520"/>
+            <a:ext cx="8595360" cy="320040"/>
+          </a:xfrm>
+          <a:prstGeom prst="rect">
+            <a:avLst/>
+          </a:prstGeom>
+          <a:noFill/>
+          <a:ln/>
+        </p:spPr>
+        <p:txBody>
+          <a:bodyPr wrap="square" lIns="0" tIns="0" rIns="0" bIns="0" rtlCol="0" anchor="t"/>
+          <a:lstStyle/>
+          <a:p>
+            <a:pPr indent="0" marL="0">
+              <a:buNone/>
+            </a:pPr>
+            <a:r>
+              <a:rPr lang="es-AR" sz="1250" i="1" dirty="0">
+                <a:solidFill>
+                  <a:srgbClr val="BFDBFE"/>
+                </a:solidFill>
+              </a:rPr>
+              <a:t>Requisito crítico del pqSNARK — problema abierto</a:t>
+            </a:r>
+          </a:p>
+        </p:txBody>
+      </p:sp>
+      <p:sp>
+        <p:nvSpPr>
+          <p:cNvPr id="5" name="Sep"/>
+          <p:cNvSpPr/>
+          <p:nvPr/>
+        </p:nvSpPr>
+        <p:spPr>
+          <a:xfrm>
+            <a:off x="274320" y="1051560"/>
+            <a:ext cx="8412480" cy="0"/>
+          </a:xfrm>
+          <a:prstGeom prst="line">
+            <a:avLst/>
+          </a:prstGeom>
+          <a:noFill/>
+          <a:ln w="12700">
+            <a:solidFill>
+              <a:srgbClr val="1E3A5F"/>
+            </a:solidFill>
+          </a:ln>
+        </p:spPr>
+      </p:sp>
+      <p:sp>
+        <p:nvSpPr>
+          <p:cNvPr id="6" name="BoxTopBg"/>
+          <p:cNvSpPr/>
+          <p:nvPr/>
+        </p:nvSpPr>
+        <p:spPr>
+          <a:xfrm>
+            <a:off x="274320" y="1143000"/>
+            <a:ext cx="8595360" cy="1600200"/>
+          </a:xfrm>
+          <a:prstGeom prst="rect">
+            <a:avLst/>
+          </a:prstGeom>
+          <a:solidFill>
+            <a:srgbClr val="0F1E3D"/>
+          </a:solidFill>
+          <a:ln w="19050">
+            <a:solidFill>
+              <a:srgbClr val="EF4444"/>
+            </a:solidFill>
+          </a:ln>
+        </p:spPr>
+      </p:sp>
+      <p:sp>
+        <p:nvSpPr>
+          <p:cNvPr id="7" name="BoxTopText"/>
+          <p:cNvSpPr/>
+          <p:nvPr/>
+        </p:nvSpPr>
+        <p:spPr>
+          <a:xfrm>
+            <a:off x="365760" y="1188720"/>
+            <a:ext cx="8412480" cy="1508760"/>
+          </a:xfrm>
+          <a:prstGeom prst="rect">
+            <a:avLst/>
+          </a:prstGeom>
+          <a:noFill/>
+          <a:ln/>
+        </p:spPr>
+        <p:txBody>
+          <a:bodyPr wrap="square" lIns="91440" tIns="45720" rIns="91440" bIns="45720" rtlCol="0" anchor="t"/>
+          <a:lstStyle/>
+          <a:p>
+            <a:pPr indent="0" marL="0">
+              <a:buNone/>
+            </a:pPr>
+            <a:r>
+              <a:rPr lang="es-AR" sz="1400" b="1" dirty="0">
+                <a:solidFill>
+                  <a:srgbClr val="EF4444"/>
+                </a:solidFill>
+                <a:latin typeface="Arial" pitchFamily="34" charset="0"/>
+              </a:rPr>
+              <a:t>El problema</a:t>
+            </a:r>
+          </a:p>
+          <a:p>
+            <a:pPr indent="0" marL="0">
+              <a:buNone/>
+            </a:pPr>
+            <a:r>
+              <a:rPr lang="es-AR" sz="1100" dirty="0">
+                <a:solidFill>
+                  <a:srgbClr val="BFDBFE"/>
+                </a:solidFill>
+              </a:rPr>
+              <a:t>Para que la multi-firma agregada sea segura, el pqSNARK debe satisfacer adaptive knowledge soundness: el statement (lista de claves públicas + mensaje) puede depender de consultas al random oracle.</a:t>
+            </a:r>
+          </a:p>
+          <a:p>
+            <a:pPr indent="0" marL="0">
+              <a:buNone/>
+            </a:pPr>
+            <a:endParaRPr lang="es-AR" sz="600" dirty="0"/>
+          </a:p>
+          <a:p>
+            <a:pPr indent="0" marL="0">
+              <a:buNone/>
+            </a:pPr>
+            <a:r>
+              <a:rPr lang="es-AR" sz="1100" dirty="0">
+                <a:solidFill>
+                  <a:srgbClr val="BFDBFE"/>
+                </a:solidFill>
+              </a:rPr>
+              <a:t>Los SNARKs existentes (Plonky3, stwo) solo prueban la versión no-adaptiva formalmente. Verificar la versión adaptiva en el modelo cuántico es trabajo futuro abierto.</a:t>
+            </a:r>
+          </a:p>
+        </p:txBody>
+      </p:sp>
+      <p:sp>
+        <p:nvSpPr>
+          <p:cNvPr id="8" name="BoxBotLeftBg"/>
+          <p:cNvSpPr/>
+          <p:nvPr/>
+        </p:nvSpPr>
+        <p:spPr>
+          <a:xfrm>
+            <a:off x="274320" y="2880360"/>
+            <a:ext cx="4206240" cy="2057400"/>
+          </a:xfrm>
+          <a:prstGeom prst="rect">
+            <a:avLst/>
+          </a:prstGeom>
+          <a:solidFill>
+            <a:srgbClr val="0F1E3D"/>
+          </a:solidFill>
+          <a:ln w="19050">
+            <a:solidFill>
+              <a:srgbClr val="F59E0B"/>
+            </a:solidFill>
+          </a:ln>
+        </p:spPr>
+      </p:sp>
+      <p:sp>
+        <p:nvSpPr>
+          <p:cNvPr id="9" name="BoxBotLeftText"/>
+          <p:cNvSpPr/>
+          <p:nvPr/>
+        </p:nvSpPr>
+        <p:spPr>
+          <a:xfrm>
+            <a:off x="365760" y="2926080"/>
+            <a:ext cx="4023360" cy="1965960"/>
+          </a:xfrm>
+          <a:prstGeom prst="rect">
+            <a:avLst/>
+          </a:prstGeom>
+          <a:noFill/>
+          <a:ln/>
+        </p:spPr>
+        <p:txBody>
+          <a:bodyPr wrap="square" lIns="91440" tIns="45720" rIns="91440" bIns="45720" rtlCol="0" anchor="t"/>
+          <a:lstStyle/>
+          <a:p>
+            <a:pPr indent="0" marL="0">
+              <a:buNone/>
+            </a:pPr>
+            <a:r>
+              <a:rPr lang="es-AR" sz="1400" b="1" dirty="0">
+                <a:solidFill>
+                  <a:srgbClr val="F59E0B"/>
+                </a:solidFill>
+                <a:latin typeface="Arial" pitchFamily="34" charset="0"/>
+              </a:rPr>
+              <a:t>Trabajo futuro</a:t>
+            </a:r>
+          </a:p>
+          <a:p>
+            <a:pPr indent="0" marL="0">
+              <a:buNone/>
+            </a:pPr>
+            <a:r>
+              <a:rPr lang="es-AR" sz="1050" dirty="0">
+                <a:solidFill>
+                  <a:srgbClr val="BFDBFE"/>
+                </a:solidFill>
+              </a:rPr>
+              <a:t>• Verificar Plonky3/stwo en modelo cuántico</a:t>
+            </a:r>
+          </a:p>
+          <a:p>
+            <a:pPr indent="0" marL="0">
+              <a:buNone/>
+            </a:pPr>
+            <a:r>
+              <a:rPr lang="es-AR" sz="1050" dirty="0">
+                <a:solidFill>
+                  <a:srgbClr val="BFDBFE"/>
+                </a:solidFill>
+              </a:rPr>
+              <a:t>• Benchmarks reales de agregación</a:t>
+            </a:r>
+          </a:p>
+          <a:p>
+            <a:pPr indent="0" marL="0">
+              <a:buNone/>
+            </a:pPr>
+            <a:r>
+              <a:rPr lang="es-AR" sz="1050" dirty="0">
+                <a:solidFill>
+                  <a:srgbClr val="BFDBFE"/>
+                </a:solidFill>
+              </a:rPr>
+              <a:t>• Lifetimes más largos (L = 2³²)</a:t>
+            </a:r>
+          </a:p>
+          <a:p>
+            <a:pPr indent="0" marL="0">
+              <a:buNone/>
+            </a:pPr>
+            <a:r>
+              <a:rPr lang="es-AR" sz="1050" dirty="0">
+                <a:solidFill>
+                  <a:srgbClr val="BFDBFE"/>
+                </a:solidFill>
+              </a:rPr>
+              <a:t>• Multi-tree XMSS con gestión eficiente</a:t>
+            </a:r>
+          </a:p>
+        </p:txBody>
+      </p:sp>
+      <p:sp>
+        <p:nvSpPr>
+          <p:cNvPr id="10" name="BoxBotRightBg"/>
+          <p:cNvSpPr/>
+          <p:nvPr/>
+        </p:nvSpPr>
+        <p:spPr>
+          <a:xfrm>
+            <a:off x="4663440" y="2880360"/>
+            <a:ext cx="4206240" cy="2057400"/>
+          </a:xfrm>
+          <a:prstGeom prst="rect">
+            <a:avLst/>
+          </a:prstGeom>
+          <a:solidFill>
+            <a:srgbClr val="0F1E3D"/>
+          </a:solidFill>
+          <a:ln w="19050">
+            <a:solidFill>
+              <a:srgbClr val="10B981"/>
+            </a:solidFill>
+          </a:ln>
+        </p:spPr>
+      </p:sp>
+      <p:sp>
+        <p:nvSpPr>
+          <p:cNvPr id="11" name="BoxBotRightText"/>
+          <p:cNvSpPr/>
+          <p:nvPr/>
+        </p:nvSpPr>
+        <p:spPr>
+          <a:xfrm>
+            <a:off x="4754880" y="2926080"/>
+            <a:ext cx="4023360" cy="1965960"/>
+          </a:xfrm>
+          <a:prstGeom prst="rect">
+            <a:avLst/>
+          </a:prstGeom>
+          <a:noFill/>
+          <a:ln/>
+        </p:spPr>
+        <p:txBody>
+          <a:bodyPr wrap="square" lIns="91440" tIns="45720" rIns="91440" bIns="45720" rtlCol="0" anchor="t"/>
+          <a:lstStyle/>
+          <a:p>
+            <a:pPr indent="0" marL="0">
+              <a:buNone/>
+            </a:pPr>
+            <a:r>
+              <a:rPr lang="es-AR" sz="1400" b="1" dirty="0">
+                <a:solidFill>
+                  <a:srgbClr val="10B981"/>
+                </a:solidFill>
+                <a:latin typeface="Arial" pitchFamily="34" charset="0"/>
+              </a:rPr>
+              <a:t>Impacto práctico</a:t>
+            </a:r>
+          </a:p>
+          <a:p>
+            <a:pPr indent="0" marL="0">
+              <a:buNone/>
+            </a:pPr>
+            <a:r>
+              <a:rPr lang="es-AR" sz="1050" dirty="0">
+                <a:solidFill>
+                  <a:srgbClr val="BFDBFE"/>
+                </a:solidFill>
+              </a:rPr>
+              <a:t>Sin esta propiedad, la seguridad formal de la multi-firma no está completa. El esquema funciona en la práctica, pero la prueba depende de un supuesto aún no verificado en el modelo post-cuántico.</a:t>
+            </a:r>
+          </a:p>
+          <a:p>
+            <a:pPr indent="0" marL="0">
+              <a:buNone/>
+            </a:pPr>
+            <a:endParaRPr lang="es-AR" sz="600" dirty="0"/>
+          </a:p>
+          <a:p>
+            <a:pPr indent="0" marL="0">
+              <a:buNone/>
+            </a:pPr>
+            <a:r>
+              <a:rPr lang="es-AR" sz="1050" dirty="0">
+                <a:solidFill>
+                  <a:srgbClr val="94A3B8"/>
+                </a:solidFill>
+              </a:rPr>
+              <a:t>Es el principal punto abierto del paper y un área activa de investigación en criptografía post-cuántica.</a:t>
+            </a:r>
+          </a:p>
+        </p:txBody>
+      </p:sp>
+    </p:spTree>
+  </p:cSld>
+</p:sld>
+</file>
+
 <file path=ppt/slides/slide3.xml><?xml version="1.0" encoding="utf-8"?>
 <p:sld xmlns:a="http://schemas.openxmlformats.org/drawingml/2006/main" xmlns:r="http://schemas.openxmlformats.org/officeDocument/2006/relationships" xmlns:p="http://schemas.openxmlformats.org/presentationml/2006/main">
   <p:cSld name="Slide 3">

</xml_diff>